<commit_message>
Accessibility hardening: true title placeholders on all slides, WCAG-passing bullet contrast (5.37:1)
</commit_message>
<xml_diff>
--- a/slides/career/business-strategy-essentials.pptx
+++ b/slides/career/business-strategy-essentials.pptx
@@ -4867,7 +4867,40 @@
       <p:grpSpPr/>
       <p:sp>
         <p:nvSpPr>
-          <p:cNvPr id="2" name="TextBox 1" descr="Course label"/>
+          <p:cNvPr id="2" name="Title 1" descr="Slide title: Business Strategy Essentials"/>
+          <p:cNvSpPr>
+            <a:spLocks noGrp="1"/>
+          </p:cNvSpPr>
+          <p:nvPr>
+            <p:ph type="title"/>
+          </p:nvPr>
+        </p:nvSpPr>
+        <p:spPr>
+          <a:xfrm>
+            <a:off x="822960" y="1920240"/>
+            <a:ext cx="10515600" cy="1737360"/>
+          </a:xfrm>
+        </p:spPr>
+        <p:txBody>
+          <a:bodyPr wrap="square"/>
+          <a:lstStyle/>
+          <a:p>
+            <a:pPr algn="l"/>
+            <a:r>
+              <a:rPr sz="4800" b="1">
+                <a:solidFill>
+                  <a:srgbClr val="FFFFFF"/>
+                </a:solidFill>
+                <a:latin typeface="Cambria"/>
+              </a:rPr>
+              <a:t>Business Strategy Essentials</a:t>
+            </a:r>
+          </a:p>
+        </p:txBody>
+      </p:sp>
+      <p:sp>
+        <p:nvSpPr>
+          <p:cNvPr id="3" name="TextBox 2" descr="Course label"/>
           <p:cNvSpPr txBox="1"/>
           <p:nvPr/>
         </p:nvSpPr>
@@ -4900,40 +4933,6 @@
                 <a:latin typeface="Calibri"/>
               </a:rPr>
               <a:t>PROFESSIONAL DEVELOPMENT · INSTRUCTOR'S NOTES FROM HARVARD BUSINESS SCHOOL ONLINE</a:t>
-            </a:r>
-          </a:p>
-        </p:txBody>
-      </p:sp>
-      <p:sp>
-        <p:nvSpPr>
-          <p:cNvPr id="3" name="TextBox 2" descr="Slide title: Business Strategy Essentials"/>
-          <p:cNvSpPr txBox="1"/>
-          <p:nvPr/>
-        </p:nvSpPr>
-        <p:spPr>
-          <a:xfrm>
-            <a:off x="822960" y="1920240"/>
-            <a:ext cx="10515600" cy="1737360"/>
-          </a:xfrm>
-          <a:prstGeom prst="rect">
-            <a:avLst/>
-          </a:prstGeom>
-          <a:noFill/>
-        </p:spPr>
-        <p:txBody>
-          <a:bodyPr wrap="square">
-            <a:spAutoFit/>
-          </a:bodyPr>
-          <a:lstStyle/>
-          <a:p>
-            <a:r>
-              <a:rPr sz="4800" b="1">
-                <a:solidFill>
-                  <a:srgbClr val="FFFFFF"/>
-                </a:solidFill>
-                <a:latin typeface="Cambria"/>
-              </a:rPr>
-              <a:t>Business Strategy Essentials</a:t>
             </a:r>
           </a:p>
         </p:txBody>
@@ -5044,7 +5043,40 @@
       <p:grpSpPr/>
       <p:sp>
         <p:nvSpPr>
-          <p:cNvPr id="2" name="TextBox 1" descr="Section number 03"/>
+          <p:cNvPr id="2" name="Title 1" descr="Slide title: Complements &amp; network effects"/>
+          <p:cNvSpPr>
+            <a:spLocks noGrp="1"/>
+          </p:cNvSpPr>
+          <p:nvPr>
+            <p:ph type="title"/>
+          </p:nvPr>
+        </p:nvSpPr>
+        <p:spPr>
+          <a:xfrm>
+            <a:off x="822960" y="2834640"/>
+            <a:ext cx="10515600" cy="914400"/>
+          </a:xfrm>
+        </p:spPr>
+        <p:txBody>
+          <a:bodyPr wrap="square"/>
+          <a:lstStyle/>
+          <a:p>
+            <a:pPr algn="l"/>
+            <a:r>
+              <a:rPr sz="4000" b="1">
+                <a:solidFill>
+                  <a:srgbClr val="FFFFFF"/>
+                </a:solidFill>
+                <a:latin typeface="Cambria"/>
+              </a:rPr>
+              <a:t>Complements &amp; network effects</a:t>
+            </a:r>
+          </a:p>
+        </p:txBody>
+      </p:sp>
+      <p:sp>
+        <p:nvSpPr>
+          <p:cNvPr id="3" name="TextBox 2" descr="Section number 03"/>
           <p:cNvSpPr txBox="1"/>
           <p:nvPr/>
         </p:nvSpPr>
@@ -5077,40 +5109,6 @@
                 <a:latin typeface="Cambria"/>
               </a:rPr>
               <a:t>03</a:t>
-            </a:r>
-          </a:p>
-        </p:txBody>
-      </p:sp>
-      <p:sp>
-        <p:nvSpPr>
-          <p:cNvPr id="3" name="TextBox 2" descr="Slide title: Complements &amp; network effects"/>
-          <p:cNvSpPr txBox="1"/>
-          <p:nvPr/>
-        </p:nvSpPr>
-        <p:spPr>
-          <a:xfrm>
-            <a:off x="822960" y="2834640"/>
-            <a:ext cx="10515600" cy="914400"/>
-          </a:xfrm>
-          <a:prstGeom prst="rect">
-            <a:avLst/>
-          </a:prstGeom>
-          <a:noFill/>
-        </p:spPr>
-        <p:txBody>
-          <a:bodyPr wrap="square">
-            <a:spAutoFit/>
-          </a:bodyPr>
-          <a:lstStyle/>
-          <a:p>
-            <a:r>
-              <a:rPr sz="4000" b="1">
-                <a:solidFill>
-                  <a:srgbClr val="FFFFFF"/>
-                </a:solidFill>
-                <a:latin typeface="Cambria"/>
-              </a:rPr>
-              <a:t>Complements &amp; network effects</a:t>
             </a:r>
           </a:p>
         </p:txBody>
@@ -5251,26 +5249,25 @@
       <p:grpSpPr/>
       <p:sp>
         <p:nvSpPr>
-          <p:cNvPr id="2" name="TextBox 1" descr="Slide title: Complements: the helpers that raise your value"/>
-          <p:cNvSpPr txBox="1"/>
-          <p:nvPr/>
+          <p:cNvPr id="2" name="Title 1" descr="Slide title: Complements: the helpers that raise your value"/>
+          <p:cNvSpPr>
+            <a:spLocks noGrp="1"/>
+          </p:cNvSpPr>
+          <p:nvPr>
+            <p:ph type="title"/>
+          </p:nvPr>
         </p:nvSpPr>
         <p:spPr>
           <a:xfrm>
             <a:off x="502920" y="411480"/>
             <a:ext cx="11155680" cy="914400"/>
           </a:xfrm>
-          <a:prstGeom prst="rect">
-            <a:avLst/>
-          </a:prstGeom>
-          <a:noFill/>
-        </p:spPr>
-        <p:txBody>
-          <a:bodyPr wrap="square">
-            <a:spAutoFit/>
-          </a:bodyPr>
-          <a:lstStyle/>
-          <a:p>
+        </p:spPr>
+        <p:txBody>
+          <a:bodyPr wrap="square"/>
+          <a:lstStyle/>
+          <a:p>
+            <a:pPr algn="l"/>
             <a:r>
               <a:rPr sz="3200" b="1">
                 <a:solidFill>
@@ -5416,7 +5413,7 @@
             <a:r>
               <a:rPr sz="1500">
                 <a:solidFill>
-                  <a:srgbClr val="C9931A"/>
+                  <a:srgbClr val="8A6410"/>
                 </a:solidFill>
                 <a:latin typeface="Calibri"/>
               </a:rPr>
@@ -5441,7 +5438,7 @@
             <a:r>
               <a:rPr sz="1500">
                 <a:solidFill>
-                  <a:srgbClr val="C9931A"/>
+                  <a:srgbClr val="8A6410"/>
                 </a:solidFill>
                 <a:latin typeface="Calibri"/>
               </a:rPr>
@@ -5466,7 +5463,7 @@
             <a:r>
               <a:rPr sz="1500">
                 <a:solidFill>
-                  <a:srgbClr val="C9931A"/>
+                  <a:srgbClr val="8A6410"/>
                 </a:solidFill>
                 <a:latin typeface="Calibri"/>
               </a:rPr>
@@ -5491,7 +5488,7 @@
             <a:r>
               <a:rPr sz="1500">
                 <a:solidFill>
-                  <a:srgbClr val="C9931A"/>
+                  <a:srgbClr val="8A6410"/>
                 </a:solidFill>
                 <a:latin typeface="Calibri"/>
               </a:rPr>
@@ -5573,7 +5570,7 @@
             <a:r>
               <a:rPr sz="1500">
                 <a:solidFill>
-                  <a:srgbClr val="C9931A"/>
+                  <a:srgbClr val="8A6410"/>
                 </a:solidFill>
                 <a:latin typeface="Calibri"/>
               </a:rPr>
@@ -5598,7 +5595,7 @@
             <a:r>
               <a:rPr sz="1500">
                 <a:solidFill>
-                  <a:srgbClr val="C9931A"/>
+                  <a:srgbClr val="8A6410"/>
                 </a:solidFill>
                 <a:latin typeface="Calibri"/>
               </a:rPr>
@@ -5623,7 +5620,7 @@
             <a:r>
               <a:rPr sz="1500">
                 <a:solidFill>
-                  <a:srgbClr val="C9931A"/>
+                  <a:srgbClr val="8A6410"/>
                 </a:solidFill>
                 <a:latin typeface="Calibri"/>
               </a:rPr>
@@ -5648,7 +5645,7 @@
             <a:r>
               <a:rPr sz="1500">
                 <a:solidFill>
-                  <a:srgbClr val="C9931A"/>
+                  <a:srgbClr val="8A6410"/>
                 </a:solidFill>
                 <a:latin typeface="Calibri"/>
               </a:rPr>
@@ -5703,26 +5700,25 @@
       <p:grpSpPr/>
       <p:sp>
         <p:nvSpPr>
-          <p:cNvPr id="2" name="TextBox 1" descr="Slide title: Network effects and tipping points"/>
-          <p:cNvSpPr txBox="1"/>
-          <p:nvPr/>
+          <p:cNvPr id="2" name="Title 1" descr="Slide title: Network effects and tipping points"/>
+          <p:cNvSpPr>
+            <a:spLocks noGrp="1"/>
+          </p:cNvSpPr>
+          <p:nvPr>
+            <p:ph type="title"/>
+          </p:nvPr>
         </p:nvSpPr>
         <p:spPr>
           <a:xfrm>
             <a:off x="502920" y="411480"/>
             <a:ext cx="11155680" cy="914400"/>
           </a:xfrm>
-          <a:prstGeom prst="rect">
-            <a:avLst/>
-          </a:prstGeom>
-          <a:noFill/>
-        </p:spPr>
-        <p:txBody>
-          <a:bodyPr wrap="square">
-            <a:spAutoFit/>
-          </a:bodyPr>
-          <a:lstStyle/>
-          <a:p>
+        </p:spPr>
+        <p:txBody>
+          <a:bodyPr wrap="square"/>
+          <a:lstStyle/>
+          <a:p>
+            <a:pPr algn="l"/>
             <a:r>
               <a:rPr sz="3200" b="1">
                 <a:solidFill>
@@ -5907,7 +5903,7 @@
             <a:r>
               <a:rPr sz="1600">
                 <a:solidFill>
-                  <a:srgbClr val="C9931A"/>
+                  <a:srgbClr val="8A6410"/>
                 </a:solidFill>
                 <a:latin typeface="Calibri"/>
               </a:rPr>
@@ -5941,7 +5937,7 @@
             <a:r>
               <a:rPr sz="1600">
                 <a:solidFill>
-                  <a:srgbClr val="C9931A"/>
+                  <a:srgbClr val="8A6410"/>
                 </a:solidFill>
                 <a:latin typeface="Calibri"/>
               </a:rPr>
@@ -5975,7 +5971,7 @@
             <a:r>
               <a:rPr sz="1600">
                 <a:solidFill>
-                  <a:srgbClr val="C9931A"/>
+                  <a:srgbClr val="8A6410"/>
                 </a:solidFill>
                 <a:latin typeface="Calibri"/>
               </a:rPr>
@@ -6030,7 +6026,40 @@
       <p:grpSpPr/>
       <p:sp>
         <p:nvSpPr>
-          <p:cNvPr id="2" name="TextBox 1" descr="Section number 04"/>
+          <p:cNvPr id="2" name="Title 1" descr="Slide title: People — the other half of the stick"/>
+          <p:cNvSpPr>
+            <a:spLocks noGrp="1"/>
+          </p:cNvSpPr>
+          <p:nvPr>
+            <p:ph type="title"/>
+          </p:nvPr>
+        </p:nvSpPr>
+        <p:spPr>
+          <a:xfrm>
+            <a:off x="822960" y="2834640"/>
+            <a:ext cx="10515600" cy="914400"/>
+          </a:xfrm>
+        </p:spPr>
+        <p:txBody>
+          <a:bodyPr wrap="square"/>
+          <a:lstStyle/>
+          <a:p>
+            <a:pPr algn="l"/>
+            <a:r>
+              <a:rPr sz="4000" b="1">
+                <a:solidFill>
+                  <a:srgbClr val="FFFFFF"/>
+                </a:solidFill>
+                <a:latin typeface="Cambria"/>
+              </a:rPr>
+              <a:t>People — the other half of the stick</a:t>
+            </a:r>
+          </a:p>
+        </p:txBody>
+      </p:sp>
+      <p:sp>
+        <p:nvSpPr>
+          <p:cNvPr id="3" name="TextBox 2" descr="Section number 04"/>
           <p:cNvSpPr txBox="1"/>
           <p:nvPr/>
         </p:nvSpPr>
@@ -6063,40 +6092,6 @@
                 <a:latin typeface="Cambria"/>
               </a:rPr>
               <a:t>04</a:t>
-            </a:r>
-          </a:p>
-        </p:txBody>
-      </p:sp>
-      <p:sp>
-        <p:nvSpPr>
-          <p:cNvPr id="3" name="TextBox 2" descr="Slide title: People — the other half of the stick"/>
-          <p:cNvSpPr txBox="1"/>
-          <p:nvPr/>
-        </p:nvSpPr>
-        <p:spPr>
-          <a:xfrm>
-            <a:off x="822960" y="2834640"/>
-            <a:ext cx="10515600" cy="914400"/>
-          </a:xfrm>
-          <a:prstGeom prst="rect">
-            <a:avLst/>
-          </a:prstGeom>
-          <a:noFill/>
-        </p:spPr>
-        <p:txBody>
-          <a:bodyPr wrap="square">
-            <a:spAutoFit/>
-          </a:bodyPr>
-          <a:lstStyle/>
-          <a:p>
-            <a:r>
-              <a:rPr sz="4000" b="1">
-                <a:solidFill>
-                  <a:srgbClr val="FFFFFF"/>
-                </a:solidFill>
-                <a:latin typeface="Cambria"/>
-              </a:rPr>
-              <a:t>People — the other half of the stick</a:t>
             </a:r>
           </a:p>
         </p:txBody>
@@ -6237,26 +6232,25 @@
       <p:grpSpPr/>
       <p:sp>
         <p:nvSpPr>
-          <p:cNvPr id="2" name="TextBox 1" descr="Slide title: Value for employees: 'feeling heard' is a strategy"/>
-          <p:cNvSpPr txBox="1"/>
-          <p:nvPr/>
+          <p:cNvPr id="2" name="Title 1" descr="Slide title: Value for employees: 'feeling heard' is a strategy"/>
+          <p:cNvSpPr>
+            <a:spLocks noGrp="1"/>
+          </p:cNvSpPr>
+          <p:nvPr>
+            <p:ph type="title"/>
+          </p:nvPr>
         </p:nvSpPr>
         <p:spPr>
           <a:xfrm>
             <a:off x="502920" y="411480"/>
             <a:ext cx="11155680" cy="914400"/>
           </a:xfrm>
-          <a:prstGeom prst="rect">
-            <a:avLst/>
-          </a:prstGeom>
-          <a:noFill/>
-        </p:spPr>
-        <p:txBody>
-          <a:bodyPr wrap="square">
-            <a:spAutoFit/>
-          </a:bodyPr>
-          <a:lstStyle/>
-          <a:p>
+        </p:spPr>
+        <p:txBody>
+          <a:bodyPr wrap="square"/>
+          <a:lstStyle/>
+          <a:p>
+            <a:pPr algn="l"/>
             <a:r>
               <a:rPr sz="3200" b="1">
                 <a:solidFill>
@@ -6368,7 +6362,7 @@
             <a:r>
               <a:rPr sz="1700">
                 <a:solidFill>
-                  <a:srgbClr val="C9931A"/>
+                  <a:srgbClr val="8A6410"/>
                 </a:solidFill>
                 <a:latin typeface="Calibri"/>
               </a:rPr>
@@ -6402,7 +6396,7 @@
             <a:r>
               <a:rPr sz="1700">
                 <a:solidFill>
-                  <a:srgbClr val="C9931A"/>
+                  <a:srgbClr val="8A6410"/>
                 </a:solidFill>
                 <a:latin typeface="Calibri"/>
               </a:rPr>
@@ -6436,7 +6430,7 @@
             <a:r>
               <a:rPr sz="1700">
                 <a:solidFill>
-                  <a:srgbClr val="C9931A"/>
+                  <a:srgbClr val="8A6410"/>
                 </a:solidFill>
                 <a:latin typeface="Calibri"/>
               </a:rPr>
@@ -6470,7 +6464,7 @@
             <a:r>
               <a:rPr sz="1700">
                 <a:solidFill>
-                  <a:srgbClr val="C9931A"/>
+                  <a:srgbClr val="8A6410"/>
                 </a:solidFill>
                 <a:latin typeface="Calibri"/>
               </a:rPr>
@@ -6525,7 +6519,40 @@
       <p:grpSpPr/>
       <p:sp>
         <p:nvSpPr>
-          <p:cNvPr id="2" name="TextBox 1" descr="Section number 05"/>
+          <p:cNvPr id="2" name="Title 1" descr="Slide title: Execution"/>
+          <p:cNvSpPr>
+            <a:spLocks noGrp="1"/>
+          </p:cNvSpPr>
+          <p:nvPr>
+            <p:ph type="title"/>
+          </p:nvPr>
+        </p:nvSpPr>
+        <p:spPr>
+          <a:xfrm>
+            <a:off x="822960" y="2834640"/>
+            <a:ext cx="10515600" cy="914400"/>
+          </a:xfrm>
+        </p:spPr>
+        <p:txBody>
+          <a:bodyPr wrap="square"/>
+          <a:lstStyle/>
+          <a:p>
+            <a:pPr algn="l"/>
+            <a:r>
+              <a:rPr sz="4000" b="1">
+                <a:solidFill>
+                  <a:srgbClr val="FFFFFF"/>
+                </a:solidFill>
+                <a:latin typeface="Cambria"/>
+              </a:rPr>
+              <a:t>Execution</a:t>
+            </a:r>
+          </a:p>
+        </p:txBody>
+      </p:sp>
+      <p:sp>
+        <p:nvSpPr>
+          <p:cNvPr id="3" name="TextBox 2" descr="Section number 05"/>
           <p:cNvSpPr txBox="1"/>
           <p:nvPr/>
         </p:nvSpPr>
@@ -6558,40 +6585,6 @@
                 <a:latin typeface="Cambria"/>
               </a:rPr>
               <a:t>05</a:t>
-            </a:r>
-          </a:p>
-        </p:txBody>
-      </p:sp>
-      <p:sp>
-        <p:nvSpPr>
-          <p:cNvPr id="3" name="TextBox 2" descr="Slide title: Execution"/>
-          <p:cNvSpPr txBox="1"/>
-          <p:nvPr/>
-        </p:nvSpPr>
-        <p:spPr>
-          <a:xfrm>
-            <a:off x="822960" y="2834640"/>
-            <a:ext cx="10515600" cy="914400"/>
-          </a:xfrm>
-          <a:prstGeom prst="rect">
-            <a:avLst/>
-          </a:prstGeom>
-          <a:noFill/>
-        </p:spPr>
-        <p:txBody>
-          <a:bodyPr wrap="square">
-            <a:spAutoFit/>
-          </a:bodyPr>
-          <a:lstStyle/>
-          <a:p>
-            <a:r>
-              <a:rPr sz="4000" b="1">
-                <a:solidFill>
-                  <a:srgbClr val="FFFFFF"/>
-                </a:solidFill>
-                <a:latin typeface="Cambria"/>
-              </a:rPr>
-              <a:t>Execution</a:t>
             </a:r>
           </a:p>
         </p:txBody>
@@ -6732,26 +6725,25 @@
       <p:grpSpPr/>
       <p:sp>
         <p:nvSpPr>
-          <p:cNvPr id="2" name="TextBox 1" descr="Slide title: From idea to action: making strategy visible"/>
-          <p:cNvSpPr txBox="1"/>
-          <p:nvPr/>
+          <p:cNvPr id="2" name="Title 1" descr="Slide title: From idea to action: making strategy visible"/>
+          <p:cNvSpPr>
+            <a:spLocks noGrp="1"/>
+          </p:cNvSpPr>
+          <p:nvPr>
+            <p:ph type="title"/>
+          </p:nvPr>
         </p:nvSpPr>
         <p:spPr>
           <a:xfrm>
             <a:off x="502920" y="411480"/>
             <a:ext cx="11155680" cy="914400"/>
           </a:xfrm>
-          <a:prstGeom prst="rect">
-            <a:avLst/>
-          </a:prstGeom>
-          <a:noFill/>
-        </p:spPr>
-        <p:txBody>
-          <a:bodyPr wrap="square">
-            <a:spAutoFit/>
-          </a:bodyPr>
-          <a:lstStyle/>
-          <a:p>
+        </p:spPr>
+        <p:txBody>
+          <a:bodyPr wrap="square"/>
+          <a:lstStyle/>
+          <a:p>
+            <a:pPr algn="l"/>
             <a:r>
               <a:rPr sz="3200" b="1">
                 <a:solidFill>
@@ -7293,26 +7285,25 @@
       <p:grpSpPr/>
       <p:sp>
         <p:nvSpPr>
-          <p:cNvPr id="2" name="TextBox 1" descr="Slide title: Using this in BADM 225 — and in your first job"/>
-          <p:cNvSpPr txBox="1"/>
-          <p:nvPr/>
+          <p:cNvPr id="2" name="Title 1" descr="Slide title: Using this in BADM 225 — and in your first job"/>
+          <p:cNvSpPr>
+            <a:spLocks noGrp="1"/>
+          </p:cNvSpPr>
+          <p:nvPr>
+            <p:ph type="title"/>
+          </p:nvPr>
         </p:nvSpPr>
         <p:spPr>
           <a:xfrm>
             <a:off x="502920" y="411480"/>
             <a:ext cx="11155680" cy="914400"/>
           </a:xfrm>
-          <a:prstGeom prst="rect">
-            <a:avLst/>
-          </a:prstGeom>
-          <a:noFill/>
-        </p:spPr>
-        <p:txBody>
-          <a:bodyPr wrap="square">
-            <a:spAutoFit/>
-          </a:bodyPr>
-          <a:lstStyle/>
-          <a:p>
+        </p:spPr>
+        <p:txBody>
+          <a:bodyPr wrap="square"/>
+          <a:lstStyle/>
+          <a:p>
+            <a:pPr algn="l"/>
             <a:r>
               <a:rPr sz="3200" b="1">
                 <a:solidFill>
@@ -7424,7 +7415,7 @@
             <a:r>
               <a:rPr sz="1700">
                 <a:solidFill>
-                  <a:srgbClr val="C9931A"/>
+                  <a:srgbClr val="8A6410"/>
                 </a:solidFill>
                 <a:latin typeface="Calibri"/>
               </a:rPr>
@@ -7458,7 +7449,7 @@
             <a:r>
               <a:rPr sz="1700">
                 <a:solidFill>
-                  <a:srgbClr val="C9931A"/>
+                  <a:srgbClr val="8A6410"/>
                 </a:solidFill>
                 <a:latin typeface="Calibri"/>
               </a:rPr>
@@ -7492,7 +7483,7 @@
             <a:r>
               <a:rPr sz="1700">
                 <a:solidFill>
-                  <a:srgbClr val="C9931A"/>
+                  <a:srgbClr val="8A6410"/>
                 </a:solidFill>
                 <a:latin typeface="Calibri"/>
               </a:rPr>
@@ -7526,7 +7517,7 @@
             <a:r>
               <a:rPr sz="1700">
                 <a:solidFill>
-                  <a:srgbClr val="C9931A"/>
+                  <a:srgbClr val="8A6410"/>
                 </a:solidFill>
                 <a:latin typeface="Calibri"/>
               </a:rPr>
@@ -7581,26 +7572,25 @@
       <p:grpSpPr/>
       <p:sp>
         <p:nvSpPr>
-          <p:cNvPr id="2" name="TextBox 1" descr="Slide title: Key takeaways"/>
-          <p:cNvSpPr txBox="1"/>
-          <p:nvPr/>
+          <p:cNvPr id="2" name="Title 1" descr="Slide title: Key takeaways"/>
+          <p:cNvSpPr>
+            <a:spLocks noGrp="1"/>
+          </p:cNvSpPr>
+          <p:nvPr>
+            <p:ph type="title"/>
+          </p:nvPr>
         </p:nvSpPr>
         <p:spPr>
           <a:xfrm>
             <a:off x="502920" y="411480"/>
             <a:ext cx="11155680" cy="914400"/>
           </a:xfrm>
-          <a:prstGeom prst="rect">
-            <a:avLst/>
-          </a:prstGeom>
-          <a:noFill/>
-        </p:spPr>
-        <p:txBody>
-          <a:bodyPr wrap="square">
-            <a:spAutoFit/>
-          </a:bodyPr>
-          <a:lstStyle/>
-          <a:p>
+        </p:spPr>
+        <p:txBody>
+          <a:bodyPr wrap="square"/>
+          <a:lstStyle/>
+          <a:p>
+            <a:pPr algn="l"/>
             <a:r>
               <a:rPr sz="3200" b="1">
                 <a:solidFill>
@@ -8319,26 +8309,25 @@
       <p:grpSpPr/>
       <p:sp>
         <p:nvSpPr>
-          <p:cNvPr id="2" name="TextBox 1" descr="Slide title: Go to the source — strongly recommended"/>
-          <p:cNvSpPr txBox="1"/>
-          <p:nvPr/>
+          <p:cNvPr id="2" name="Title 1" descr="Slide title: Go to the source — strongly recommended"/>
+          <p:cNvSpPr>
+            <a:spLocks noGrp="1"/>
+          </p:cNvSpPr>
+          <p:nvPr>
+            <p:ph type="title"/>
+          </p:nvPr>
         </p:nvSpPr>
         <p:spPr>
           <a:xfrm>
             <a:off x="502920" y="411480"/>
             <a:ext cx="11155680" cy="914400"/>
           </a:xfrm>
-          <a:prstGeom prst="rect">
-            <a:avLst/>
-          </a:prstGeom>
-          <a:noFill/>
-        </p:spPr>
-        <p:txBody>
-          <a:bodyPr wrap="square">
-            <a:spAutoFit/>
-          </a:bodyPr>
-          <a:lstStyle/>
-          <a:p>
+        </p:spPr>
+        <p:txBody>
+          <a:bodyPr wrap="square"/>
+          <a:lstStyle/>
+          <a:p>
+            <a:pPr algn="l"/>
             <a:r>
               <a:rPr sz="3200" b="1">
                 <a:solidFill>
@@ -8450,7 +8439,7 @@
             <a:r>
               <a:rPr sz="1700">
                 <a:solidFill>
-                  <a:srgbClr val="C9931A"/>
+                  <a:srgbClr val="8A6410"/>
                 </a:solidFill>
                 <a:latin typeface="Calibri"/>
               </a:rPr>
@@ -8484,7 +8473,7 @@
             <a:r>
               <a:rPr sz="1700">
                 <a:solidFill>
-                  <a:srgbClr val="C9931A"/>
+                  <a:srgbClr val="8A6410"/>
                 </a:solidFill>
                 <a:latin typeface="Calibri"/>
               </a:rPr>
@@ -8518,7 +8507,7 @@
             <a:r>
               <a:rPr sz="1700">
                 <a:solidFill>
-                  <a:srgbClr val="C9931A"/>
+                  <a:srgbClr val="8A6410"/>
                 </a:solidFill>
                 <a:latin typeface="Calibri"/>
               </a:rPr>
@@ -8552,7 +8541,7 @@
             <a:r>
               <a:rPr sz="1700">
                 <a:solidFill>
-                  <a:srgbClr val="C9931A"/>
+                  <a:srgbClr val="8A6410"/>
                 </a:solidFill>
                 <a:latin typeface="Calibri"/>
               </a:rPr>
@@ -8607,26 +8596,25 @@
       <p:grpSpPr/>
       <p:sp>
         <p:nvSpPr>
-          <p:cNvPr id="2" name="TextBox 1" descr="Slide title: Why a strategy lecture in a communication course?"/>
-          <p:cNvSpPr txBox="1"/>
-          <p:nvPr/>
+          <p:cNvPr id="2" name="Title 1" descr="Slide title: Why a strategy lecture in a communication course?"/>
+          <p:cNvSpPr>
+            <a:spLocks noGrp="1"/>
+          </p:cNvSpPr>
+          <p:nvPr>
+            <p:ph type="title"/>
+          </p:nvPr>
         </p:nvSpPr>
         <p:spPr>
           <a:xfrm>
             <a:off x="502920" y="411480"/>
             <a:ext cx="11155680" cy="914400"/>
           </a:xfrm>
-          <a:prstGeom prst="rect">
-            <a:avLst/>
-          </a:prstGeom>
-          <a:noFill/>
-        </p:spPr>
-        <p:txBody>
-          <a:bodyPr wrap="square">
-            <a:spAutoFit/>
-          </a:bodyPr>
-          <a:lstStyle/>
-          <a:p>
+        </p:spPr>
+        <p:txBody>
+          <a:bodyPr wrap="square"/>
+          <a:lstStyle/>
+          <a:p>
+            <a:pPr algn="l"/>
             <a:r>
               <a:rPr sz="3200" b="1">
                 <a:solidFill>
@@ -8738,7 +8726,7 @@
             <a:r>
               <a:rPr sz="1700">
                 <a:solidFill>
-                  <a:srgbClr val="C9931A"/>
+                  <a:srgbClr val="8A6410"/>
                 </a:solidFill>
                 <a:latin typeface="Calibri"/>
               </a:rPr>
@@ -8772,7 +8760,7 @@
             <a:r>
               <a:rPr sz="1700">
                 <a:solidFill>
-                  <a:srgbClr val="C9931A"/>
+                  <a:srgbClr val="8A6410"/>
                 </a:solidFill>
                 <a:latin typeface="Calibri"/>
               </a:rPr>
@@ -8806,7 +8794,7 @@
             <a:r>
               <a:rPr sz="1700">
                 <a:solidFill>
-                  <a:srgbClr val="C9931A"/>
+                  <a:srgbClr val="8A6410"/>
                 </a:solidFill>
                 <a:latin typeface="Calibri"/>
               </a:rPr>
@@ -8840,7 +8828,7 @@
             <a:r>
               <a:rPr sz="1700">
                 <a:solidFill>
-                  <a:srgbClr val="C9931A"/>
+                  <a:srgbClr val="8A6410"/>
                 </a:solidFill>
                 <a:latin typeface="Calibri"/>
               </a:rPr>
@@ -8895,26 +8883,25 @@
       <p:grpSpPr/>
       <p:sp>
         <p:nvSpPr>
-          <p:cNvPr id="2" name="TextBox 1" descr="Slide title: Discussion questions"/>
-          <p:cNvSpPr txBox="1"/>
-          <p:nvPr/>
+          <p:cNvPr id="2" name="Title 1" descr="Slide title: Discussion questions"/>
+          <p:cNvSpPr>
+            <a:spLocks noGrp="1"/>
+          </p:cNvSpPr>
+          <p:nvPr>
+            <p:ph type="title"/>
+          </p:nvPr>
         </p:nvSpPr>
         <p:spPr>
           <a:xfrm>
             <a:off x="502920" y="411480"/>
             <a:ext cx="11155680" cy="914400"/>
           </a:xfrm>
-          <a:prstGeom prst="rect">
-            <a:avLst/>
-          </a:prstGeom>
-          <a:noFill/>
-        </p:spPr>
-        <p:txBody>
-          <a:bodyPr wrap="square">
-            <a:spAutoFit/>
-          </a:bodyPr>
-          <a:lstStyle/>
-          <a:p>
+        </p:spPr>
+        <p:txBody>
+          <a:bodyPr wrap="square"/>
+          <a:lstStyle/>
+          <a:p>
+            <a:pPr algn="l"/>
             <a:r>
               <a:rPr sz="3400" b="1">
                 <a:solidFill>
@@ -9137,26 +9124,25 @@
       <p:grpSpPr/>
       <p:sp>
         <p:nvSpPr>
-          <p:cNvPr id="2" name="TextBox 1" descr="Slide title: The core idea, in one sentence"/>
-          <p:cNvSpPr txBox="1"/>
-          <p:nvPr/>
+          <p:cNvPr id="2" name="Title 1" descr="Slide title: The core idea, in one sentence"/>
+          <p:cNvSpPr>
+            <a:spLocks noGrp="1"/>
+          </p:cNvSpPr>
+          <p:nvPr>
+            <p:ph type="title"/>
+          </p:nvPr>
         </p:nvSpPr>
         <p:spPr>
           <a:xfrm>
             <a:off x="502920" y="411480"/>
             <a:ext cx="11155680" cy="914400"/>
           </a:xfrm>
-          <a:prstGeom prst="rect">
-            <a:avLst/>
-          </a:prstGeom>
-          <a:noFill/>
-        </p:spPr>
-        <p:txBody>
-          <a:bodyPr wrap="square">
-            <a:spAutoFit/>
-          </a:bodyPr>
-          <a:lstStyle/>
-          <a:p>
+        </p:spPr>
+        <p:txBody>
+          <a:bodyPr wrap="square"/>
+          <a:lstStyle/>
+          <a:p>
+            <a:pPr algn="l"/>
             <a:r>
               <a:rPr sz="3400" b="1">
                 <a:solidFill>
@@ -9344,7 +9330,40 @@
       <p:grpSpPr/>
       <p:sp>
         <p:nvSpPr>
-          <p:cNvPr id="2" name="TextBox 1" descr="Section number 01"/>
+          <p:cNvPr id="2" name="Title 1" descr="Slide title: The value stick"/>
+          <p:cNvSpPr>
+            <a:spLocks noGrp="1"/>
+          </p:cNvSpPr>
+          <p:nvPr>
+            <p:ph type="title"/>
+          </p:nvPr>
+        </p:nvSpPr>
+        <p:spPr>
+          <a:xfrm>
+            <a:off x="822960" y="2834640"/>
+            <a:ext cx="10515600" cy="914400"/>
+          </a:xfrm>
+        </p:spPr>
+        <p:txBody>
+          <a:bodyPr wrap="square"/>
+          <a:lstStyle/>
+          <a:p>
+            <a:pPr algn="l"/>
+            <a:r>
+              <a:rPr sz="4000" b="1">
+                <a:solidFill>
+                  <a:srgbClr val="FFFFFF"/>
+                </a:solidFill>
+                <a:latin typeface="Cambria"/>
+              </a:rPr>
+              <a:t>The value stick</a:t>
+            </a:r>
+          </a:p>
+        </p:txBody>
+      </p:sp>
+      <p:sp>
+        <p:nvSpPr>
+          <p:cNvPr id="3" name="TextBox 2" descr="Section number 01"/>
           <p:cNvSpPr txBox="1"/>
           <p:nvPr/>
         </p:nvSpPr>
@@ -9377,40 +9396,6 @@
                 <a:latin typeface="Cambria"/>
               </a:rPr>
               <a:t>01</a:t>
-            </a:r>
-          </a:p>
-        </p:txBody>
-      </p:sp>
-      <p:sp>
-        <p:nvSpPr>
-          <p:cNvPr id="3" name="TextBox 2" descr="Slide title: The value stick"/>
-          <p:cNvSpPr txBox="1"/>
-          <p:nvPr/>
-        </p:nvSpPr>
-        <p:spPr>
-          <a:xfrm>
-            <a:off x="822960" y="2834640"/>
-            <a:ext cx="10515600" cy="914400"/>
-          </a:xfrm>
-          <a:prstGeom prst="rect">
-            <a:avLst/>
-          </a:prstGeom>
-          <a:noFill/>
-        </p:spPr>
-        <p:txBody>
-          <a:bodyPr wrap="square">
-            <a:spAutoFit/>
-          </a:bodyPr>
-          <a:lstStyle/>
-          <a:p>
-            <a:r>
-              <a:rPr sz="4000" b="1">
-                <a:solidFill>
-                  <a:srgbClr val="FFFFFF"/>
-                </a:solidFill>
-                <a:latin typeface="Cambria"/>
-              </a:rPr>
-              <a:t>The value stick</a:t>
             </a:r>
           </a:p>
         </p:txBody>
@@ -9551,26 +9536,25 @@
       <p:grpSpPr/>
       <p:sp>
         <p:nvSpPr>
-          <p:cNvPr id="2" name="TextBox 1" descr="Slide title: Four numbers that decide every business"/>
-          <p:cNvSpPr txBox="1"/>
-          <p:nvPr/>
+          <p:cNvPr id="2" name="Title 1" descr="Slide title: Four numbers that decide every business"/>
+          <p:cNvSpPr>
+            <a:spLocks noGrp="1"/>
+          </p:cNvSpPr>
+          <p:nvPr>
+            <p:ph type="title"/>
+          </p:nvPr>
         </p:nvSpPr>
         <p:spPr>
           <a:xfrm>
             <a:off x="502920" y="411480"/>
             <a:ext cx="11155680" cy="914400"/>
           </a:xfrm>
-          <a:prstGeom prst="rect">
-            <a:avLst/>
-          </a:prstGeom>
-          <a:noFill/>
-        </p:spPr>
-        <p:txBody>
-          <a:bodyPr wrap="square">
-            <a:spAutoFit/>
-          </a:bodyPr>
-          <a:lstStyle/>
-          <a:p>
+        </p:spPr>
+        <p:txBody>
+          <a:bodyPr wrap="square"/>
+          <a:lstStyle/>
+          <a:p>
+            <a:pPr algn="l"/>
             <a:r>
               <a:rPr sz="3200" b="1">
                 <a:solidFill>
@@ -10114,26 +10098,25 @@
       <p:grpSpPr/>
       <p:sp>
         <p:nvSpPr>
-          <p:cNvPr id="2" name="TextBox 1" descr="Slide title: Raising WTP vs. lowering WTS — the only two moves"/>
-          <p:cNvSpPr txBox="1"/>
-          <p:nvPr/>
+          <p:cNvPr id="2" name="Title 1" descr="Slide title: Raising WTP vs. lowering WTS — the only two moves"/>
+          <p:cNvSpPr>
+            <a:spLocks noGrp="1"/>
+          </p:cNvSpPr>
+          <p:nvPr>
+            <p:ph type="title"/>
+          </p:nvPr>
         </p:nvSpPr>
         <p:spPr>
           <a:xfrm>
             <a:off x="502920" y="411480"/>
             <a:ext cx="11155680" cy="914400"/>
           </a:xfrm>
-          <a:prstGeom prst="rect">
-            <a:avLst/>
-          </a:prstGeom>
-          <a:noFill/>
-        </p:spPr>
-        <p:txBody>
-          <a:bodyPr wrap="square">
-            <a:spAutoFit/>
-          </a:bodyPr>
-          <a:lstStyle/>
-          <a:p>
+        </p:spPr>
+        <p:txBody>
+          <a:bodyPr wrap="square"/>
+          <a:lstStyle/>
+          <a:p>
+            <a:pPr algn="l"/>
             <a:r>
               <a:rPr sz="3200" b="1">
                 <a:solidFill>
@@ -10279,7 +10262,7 @@
             <a:r>
               <a:rPr sz="1500">
                 <a:solidFill>
-                  <a:srgbClr val="C9931A"/>
+                  <a:srgbClr val="8A6410"/>
                 </a:solidFill>
                 <a:latin typeface="Calibri"/>
               </a:rPr>
@@ -10304,7 +10287,7 @@
             <a:r>
               <a:rPr sz="1500">
                 <a:solidFill>
-                  <a:srgbClr val="C9931A"/>
+                  <a:srgbClr val="8A6410"/>
                 </a:solidFill>
                 <a:latin typeface="Calibri"/>
               </a:rPr>
@@ -10329,7 +10312,7 @@
             <a:r>
               <a:rPr sz="1500">
                 <a:solidFill>
-                  <a:srgbClr val="C9931A"/>
+                  <a:srgbClr val="8A6410"/>
                 </a:solidFill>
                 <a:latin typeface="Calibri"/>
               </a:rPr>
@@ -10354,7 +10337,7 @@
             <a:r>
               <a:rPr sz="1500">
                 <a:solidFill>
-                  <a:srgbClr val="C9931A"/>
+                  <a:srgbClr val="8A6410"/>
                 </a:solidFill>
                 <a:latin typeface="Calibri"/>
               </a:rPr>
@@ -10445,7 +10428,7 @@
             <a:r>
               <a:rPr sz="1500">
                 <a:solidFill>
-                  <a:srgbClr val="C9931A"/>
+                  <a:srgbClr val="8A6410"/>
                 </a:solidFill>
                 <a:latin typeface="Calibri"/>
               </a:rPr>
@@ -10470,7 +10453,7 @@
             <a:r>
               <a:rPr sz="1500">
                 <a:solidFill>
-                  <a:srgbClr val="C9931A"/>
+                  <a:srgbClr val="8A6410"/>
                 </a:solidFill>
                 <a:latin typeface="Calibri"/>
               </a:rPr>
@@ -10495,7 +10478,7 @@
             <a:r>
               <a:rPr sz="1500">
                 <a:solidFill>
-                  <a:srgbClr val="C9931A"/>
+                  <a:srgbClr val="8A6410"/>
                 </a:solidFill>
                 <a:latin typeface="Calibri"/>
               </a:rPr>
@@ -10520,7 +10503,7 @@
             <a:r>
               <a:rPr sz="1500">
                 <a:solidFill>
-                  <a:srgbClr val="C9931A"/>
+                  <a:srgbClr val="8A6410"/>
                 </a:solidFill>
                 <a:latin typeface="Calibri"/>
               </a:rPr>
@@ -10575,26 +10558,25 @@
       <p:grpSpPr/>
       <p:sp>
         <p:nvSpPr>
-          <p:cNvPr id="2" name="TextBox 1" descr="Slide title: The simplicity test"/>
-          <p:cNvSpPr txBox="1"/>
-          <p:nvPr/>
+          <p:cNvPr id="2" name="Title 1" descr="Slide title: The simplicity test"/>
+          <p:cNvSpPr>
+            <a:spLocks noGrp="1"/>
+          </p:cNvSpPr>
+          <p:nvPr>
+            <p:ph type="title"/>
+          </p:nvPr>
         </p:nvSpPr>
         <p:spPr>
           <a:xfrm>
             <a:off x="502920" y="411480"/>
             <a:ext cx="11155680" cy="914400"/>
           </a:xfrm>
-          <a:prstGeom prst="rect">
-            <a:avLst/>
-          </a:prstGeom>
-          <a:noFill/>
-        </p:spPr>
-        <p:txBody>
-          <a:bodyPr wrap="square">
-            <a:spAutoFit/>
-          </a:bodyPr>
-          <a:lstStyle/>
-          <a:p>
+        </p:spPr>
+        <p:txBody>
+          <a:bodyPr wrap="square"/>
+          <a:lstStyle/>
+          <a:p>
+            <a:pPr algn="l"/>
             <a:r>
               <a:rPr sz="3200" b="1">
                 <a:solidFill>
@@ -10706,7 +10688,7 @@
             <a:r>
               <a:rPr sz="1700">
                 <a:solidFill>
-                  <a:srgbClr val="C9931A"/>
+                  <a:srgbClr val="8A6410"/>
                 </a:solidFill>
                 <a:latin typeface="Calibri"/>
               </a:rPr>
@@ -10740,7 +10722,7 @@
             <a:r>
               <a:rPr sz="1700">
                 <a:solidFill>
-                  <a:srgbClr val="C9931A"/>
+                  <a:srgbClr val="8A6410"/>
                 </a:solidFill>
                 <a:latin typeface="Calibri"/>
               </a:rPr>
@@ -10774,7 +10756,7 @@
             <a:r>
               <a:rPr sz="1700">
                 <a:solidFill>
-                  <a:srgbClr val="C9931A"/>
+                  <a:srgbClr val="8A6410"/>
                 </a:solidFill>
                 <a:latin typeface="Calibri"/>
               </a:rPr>
@@ -10808,7 +10790,7 @@
             <a:r>
               <a:rPr sz="1700">
                 <a:solidFill>
-                  <a:srgbClr val="C9931A"/>
+                  <a:srgbClr val="8A6410"/>
                 </a:solidFill>
                 <a:latin typeface="Calibri"/>
               </a:rPr>
@@ -10863,7 +10845,40 @@
       <p:grpSpPr/>
       <p:sp>
         <p:nvSpPr>
-          <p:cNvPr id="2" name="TextBox 1" descr="Section number 02"/>
+          <p:cNvPr id="2" name="Title 1" descr="Slide title: Customers"/>
+          <p:cNvSpPr>
+            <a:spLocks noGrp="1"/>
+          </p:cNvSpPr>
+          <p:nvPr>
+            <p:ph type="title"/>
+          </p:nvPr>
+        </p:nvSpPr>
+        <p:spPr>
+          <a:xfrm>
+            <a:off x="822960" y="2834640"/>
+            <a:ext cx="10515600" cy="914400"/>
+          </a:xfrm>
+        </p:spPr>
+        <p:txBody>
+          <a:bodyPr wrap="square"/>
+          <a:lstStyle/>
+          <a:p>
+            <a:pPr algn="l"/>
+            <a:r>
+              <a:rPr sz="4000" b="1">
+                <a:solidFill>
+                  <a:srgbClr val="FFFFFF"/>
+                </a:solidFill>
+                <a:latin typeface="Cambria"/>
+              </a:rPr>
+              <a:t>Customers</a:t>
+            </a:r>
+          </a:p>
+        </p:txBody>
+      </p:sp>
+      <p:sp>
+        <p:nvSpPr>
+          <p:cNvPr id="3" name="TextBox 2" descr="Section number 02"/>
           <p:cNvSpPr txBox="1"/>
           <p:nvPr/>
         </p:nvSpPr>
@@ -10896,40 +10911,6 @@
                 <a:latin typeface="Cambria"/>
               </a:rPr>
               <a:t>02</a:t>
-            </a:r>
-          </a:p>
-        </p:txBody>
-      </p:sp>
-      <p:sp>
-        <p:nvSpPr>
-          <p:cNvPr id="3" name="TextBox 2" descr="Slide title: Customers"/>
-          <p:cNvSpPr txBox="1"/>
-          <p:nvPr/>
-        </p:nvSpPr>
-        <p:spPr>
-          <a:xfrm>
-            <a:off x="822960" y="2834640"/>
-            <a:ext cx="10515600" cy="914400"/>
-          </a:xfrm>
-          <a:prstGeom prst="rect">
-            <a:avLst/>
-          </a:prstGeom>
-          <a:noFill/>
-        </p:spPr>
-        <p:txBody>
-          <a:bodyPr wrap="square">
-            <a:spAutoFit/>
-          </a:bodyPr>
-          <a:lstStyle/>
-          <a:p>
-            <a:r>
-              <a:rPr sz="4000" b="1">
-                <a:solidFill>
-                  <a:srgbClr val="FFFFFF"/>
-                </a:solidFill>
-                <a:latin typeface="Cambria"/>
-              </a:rPr>
-              <a:t>Customers</a:t>
             </a:r>
           </a:p>
         </p:txBody>
@@ -11070,26 +11051,25 @@
       <p:grpSpPr/>
       <p:sp>
         <p:nvSpPr>
-          <p:cNvPr id="2" name="TextBox 1" descr="Slide title: Finding room to raise WTP"/>
-          <p:cNvSpPr txBox="1"/>
-          <p:nvPr/>
+          <p:cNvPr id="2" name="Title 1" descr="Slide title: Finding room to raise WTP"/>
+          <p:cNvSpPr>
+            <a:spLocks noGrp="1"/>
+          </p:cNvSpPr>
+          <p:nvPr>
+            <p:ph type="title"/>
+          </p:nvPr>
         </p:nvSpPr>
         <p:spPr>
           <a:xfrm>
             <a:off x="502920" y="411480"/>
             <a:ext cx="11155680" cy="914400"/>
           </a:xfrm>
-          <a:prstGeom prst="rect">
-            <a:avLst/>
-          </a:prstGeom>
-          <a:noFill/>
-        </p:spPr>
-        <p:txBody>
-          <a:bodyPr wrap="square">
-            <a:spAutoFit/>
-          </a:bodyPr>
-          <a:lstStyle/>
-          <a:p>
+        </p:spPr>
+        <p:txBody>
+          <a:bodyPr wrap="square"/>
+          <a:lstStyle/>
+          <a:p>
+            <a:pPr algn="l"/>
             <a:r>
               <a:rPr sz="3200" b="1">
                 <a:solidFill>

</xml_diff>